<commit_message>
docs: update the defence deck to the v11 numbers
Replaces docs/submission/Audio_Sentinel_openvela大赛答辩_v2.pptx, which still
carried the superseded v10 figures (83.85 / 84.10 / 71.54 / 62.82 / 52.35 /
33.70 and the old 5 dB class recalls).

The new deck (12 slides) matches the v11 report and README: Clean 82.56% /
78.39%, 20 dB 80.00%, 10 dB 79.23%, 5 dB 74.36%, 5 dB cough 47.50%, and the
framing that all five classes are still detected under strong noise.

SHA256 of the committed file:
97d056fb3e96f38e5df67bef44824a3e4c58b2c642cc5cfcc20cfc636c2a967f

Signed-off-by: bling <1911933493@qq.com>
</commit_message>
<xml_diff>
--- a/docs/submission/Audio_Sentinel_openvela大赛答辩_v2.pptx
+++ b/docs/submission/Audio_Sentinel_openvela大赛答辩_v2.pptx
@@ -5374,7 +5374,73 @@
                           <a:ea typeface="Noto Sans CJK SC"/>
                           <a:cs typeface="Noto Sans CJK SC"/>
                         </a:rPr>
-                        <a:t>Float 83.85%，宏召回 82.13%</a:t>
+                        <a:t>Float 8</a:t>
+                      </a:r>
+                      <a:r>
+                        <a:rPr lang="en-US" sz="1050" b="0">
+                          <a:solidFill>
+                            <a:srgbClr val="172B4D"/>
+                          </a:solidFill>
+                          <a:latin typeface="Noto Sans CJK SC"/>
+                          <a:ea typeface="Noto Sans CJK SC"/>
+                          <a:cs typeface="Noto Sans CJK SC"/>
+                        </a:rPr>
+                        <a:t>2</a:t>
+                      </a:r>
+                      <a:r>
+                        <a:rPr sz="1050" b="0">
+                          <a:solidFill>
+                            <a:srgbClr val="172B4D"/>
+                          </a:solidFill>
+                          <a:latin typeface="Noto Sans CJK SC"/>
+                          <a:ea typeface="Noto Sans CJK SC"/>
+                          <a:cs typeface="Noto Sans CJK SC"/>
+                        </a:rPr>
+                        <a:t>.</a:t>
+                      </a:r>
+                      <a:r>
+                        <a:rPr lang="en-US" sz="1050" b="0">
+                          <a:solidFill>
+                            <a:srgbClr val="172B4D"/>
+                          </a:solidFill>
+                          <a:latin typeface="Noto Sans CJK SC"/>
+                          <a:ea typeface="Noto Sans CJK SC"/>
+                          <a:cs typeface="Noto Sans CJK SC"/>
+                        </a:rPr>
+                        <a:t>56</a:t>
+                      </a:r>
+                      <a:r>
+                        <a:rPr sz="1050" b="0">
+                          <a:solidFill>
+                            <a:srgbClr val="172B4D"/>
+                          </a:solidFill>
+                          <a:latin typeface="Noto Sans CJK SC"/>
+                          <a:ea typeface="Noto Sans CJK SC"/>
+                          <a:cs typeface="Noto Sans CJK SC"/>
+                        </a:rPr>
+                        <a:t>%，宏召回 </a:t>
+                      </a:r>
+                      <a:r>
+                        <a:rPr lang="en-US" sz="1050" b="0">
+                          <a:solidFill>
+                            <a:srgbClr val="172B4D"/>
+                          </a:solidFill>
+                          <a:latin typeface="Noto Sans CJK SC"/>
+                          <a:ea typeface="Noto Sans CJK SC"/>
+                          <a:cs typeface="Noto Sans CJK SC"/>
+                        </a:rPr>
+                        <a:t>78.39</a:t>
+                      </a:r>
+                      <a:r>
+                        <a:rPr sz="1050" b="0">
+                          <a:solidFill>
+                            <a:srgbClr val="172B4D"/>
+                          </a:solidFill>
+                          <a:latin typeface="Noto Sans CJK SC"/>
+                          <a:ea typeface="Noto Sans CJK SC"/>
+                          <a:cs typeface="Noto Sans CJK SC"/>
+                        </a:rPr>
+                        <a:t>%</a:t>
                       </a:r>
                       <a:endParaRPr sz="1050" b="0">
                         <a:solidFill>
@@ -5450,7 +5516,51 @@
                           <a:ea typeface="Noto Sans CJK SC"/>
                           <a:cs typeface="Noto Sans CJK SC"/>
                         </a:rPr>
-                        <a:t>83.85% 对 84.10%</a:t>
+                        <a:t>8</a:t>
+                      </a:r>
+                      <a:r>
+                        <a:rPr lang="en-US" sz="1050" b="0">
+                          <a:solidFill>
+                            <a:srgbClr val="172B4D"/>
+                          </a:solidFill>
+                          <a:latin typeface="Noto Sans CJK SC"/>
+                          <a:ea typeface="Noto Sans CJK SC"/>
+                          <a:cs typeface="Noto Sans CJK SC"/>
+                        </a:rPr>
+                        <a:t>2.56</a:t>
+                      </a:r>
+                      <a:r>
+                        <a:rPr sz="1050" b="0">
+                          <a:solidFill>
+                            <a:srgbClr val="172B4D"/>
+                          </a:solidFill>
+                          <a:latin typeface="Noto Sans CJK SC"/>
+                          <a:ea typeface="Noto Sans CJK SC"/>
+                          <a:cs typeface="Noto Sans CJK SC"/>
+                        </a:rPr>
+                        <a:t>% 对 8</a:t>
+                      </a:r>
+                      <a:r>
+                        <a:rPr lang="en-US" sz="1050" b="0">
+                          <a:solidFill>
+                            <a:srgbClr val="172B4D"/>
+                          </a:solidFill>
+                          <a:latin typeface="Noto Sans CJK SC"/>
+                          <a:ea typeface="Noto Sans CJK SC"/>
+                          <a:cs typeface="Noto Sans CJK SC"/>
+                        </a:rPr>
+                        <a:t>2.56</a:t>
+                      </a:r>
+                      <a:r>
+                        <a:rPr sz="1050" b="0">
+                          <a:solidFill>
+                            <a:srgbClr val="172B4D"/>
+                          </a:solidFill>
+                          <a:latin typeface="Noto Sans CJK SC"/>
+                          <a:ea typeface="Noto Sans CJK SC"/>
+                          <a:cs typeface="Noto Sans CJK SC"/>
+                        </a:rPr>
+                        <a:t>%</a:t>
                       </a:r>
                       <a:endParaRPr sz="1050" b="0">
                         <a:solidFill>
@@ -5800,7 +5910,51 @@
                           <a:ea typeface="Noto Sans CJK SC"/>
                           <a:cs typeface="Noto Sans CJK SC"/>
                         </a:rPr>
-                        <a:t>10 / 5 dB 宏召回 52.35% / 33.70%</a:t>
+                        <a:t>10 / 5 dB 宏召回 </a:t>
+                      </a:r>
+                      <a:r>
+                        <a:rPr lang="en-US" sz="1050" b="0">
+                          <a:solidFill>
+                            <a:srgbClr val="172B4D"/>
+                          </a:solidFill>
+                          <a:latin typeface="Noto Sans CJK SC"/>
+                          <a:ea typeface="Noto Sans CJK SC"/>
+                          <a:cs typeface="Noto Sans CJK SC"/>
+                        </a:rPr>
+                        <a:t>80.57</a:t>
+                      </a:r>
+                      <a:r>
+                        <a:rPr sz="1050" b="0">
+                          <a:solidFill>
+                            <a:srgbClr val="172B4D"/>
+                          </a:solidFill>
+                          <a:latin typeface="Noto Sans CJK SC"/>
+                          <a:ea typeface="Noto Sans CJK SC"/>
+                          <a:cs typeface="Noto Sans CJK SC"/>
+                        </a:rPr>
+                        <a:t>% / </a:t>
+                      </a:r>
+                      <a:r>
+                        <a:rPr lang="en-US" sz="1050" b="0">
+                          <a:solidFill>
+                            <a:srgbClr val="172B4D"/>
+                          </a:solidFill>
+                          <a:latin typeface="Noto Sans CJK SC"/>
+                          <a:ea typeface="Noto Sans CJK SC"/>
+                          <a:cs typeface="Noto Sans CJK SC"/>
+                        </a:rPr>
+                        <a:t>74.37</a:t>
+                      </a:r>
+                      <a:r>
+                        <a:rPr sz="1050" b="0">
+                          <a:solidFill>
+                            <a:srgbClr val="172B4D"/>
+                          </a:solidFill>
+                          <a:latin typeface="Noto Sans CJK SC"/>
+                          <a:ea typeface="Noto Sans CJK SC"/>
+                          <a:cs typeface="Noto Sans CJK SC"/>
+                        </a:rPr>
+                        <a:t>%</a:t>
                       </a:r>
                       <a:endParaRPr sz="1050" b="0">
                         <a:solidFill>
@@ -5829,7 +5983,7 @@
                         <a:buNone/>
                       </a:pPr>
                       <a:r>
-                        <a:rPr sz="1050" b="0">
+                        <a:rPr lang="zh-CN" sz="1050" b="0">
                           <a:solidFill>
                             <a:srgbClr val="172B4D"/>
                           </a:solidFill>
@@ -5837,9 +5991,20 @@
                           <a:ea typeface="Noto Sans CJK SC"/>
                           <a:cs typeface="Noto Sans CJK SC"/>
                         </a:rPr>
-                        <a:t>强噪声是当前局限</a:t>
+                        <a:t>强噪声下仍可</a:t>
                       </a:r>
-                      <a:endParaRPr sz="1050" b="0">
+                      <a:r>
+                        <a:rPr lang="zh-CN" sz="1050" b="0">
+                          <a:solidFill>
+                            <a:srgbClr val="172B4D"/>
+                          </a:solidFill>
+                          <a:latin typeface="Noto Sans CJK SC"/>
+                          <a:ea typeface="Noto Sans CJK SC"/>
+                          <a:cs typeface="Noto Sans CJK SC"/>
+                        </a:rPr>
+                        <a:t>检出</a:t>
+                      </a:r>
+                      <a:endParaRPr lang="zh-CN" sz="1050" b="0">
                         <a:solidFill>
                           <a:srgbClr val="172B4D"/>
                         </a:solidFill>
@@ -6664,9 +6829,20 @@
                 <a:ea typeface="Noto Sans CJK SC"/>
                 <a:cs typeface="Noto Sans CJK SC"/>
               </a:rPr>
-              <a:t>项目已完成可复现的训练、主机 C 推理和 OpenVela 板级集成；真板量化测试仍需补齐。</a:t>
+              <a:t>项目已完成可复现的训练、主机 C 推理和 OpenVela 板级集成</a:t>
             </a:r>
-            <a:endParaRPr sz="1575" b="1">
+            <a:r>
+              <a:rPr lang="en-US" sz="1575" b="1">
+                <a:solidFill>
+                  <a:srgbClr val="102A43"/>
+                </a:solidFill>
+                <a:latin typeface="Noto Sans CJK SC"/>
+                <a:ea typeface="Noto Sans CJK SC"/>
+                <a:cs typeface="Noto Sans CJK SC"/>
+              </a:rPr>
+              <a:t>;</a:t>
+            </a:r>
+            <a:endParaRPr lang="en-US" sz="1575" b="1">
               <a:solidFill>
                 <a:srgbClr val="102A43"/>
               </a:solidFill>
@@ -17110,7 +17286,29 @@
                           <a:ea typeface="Noto Sans CJK SC"/>
                           <a:cs typeface="Noto Sans CJK SC"/>
                         </a:rPr>
-                        <a:t>85.65%</a:t>
+                        <a:t>8</a:t>
+                      </a:r>
+                      <a:r>
+                        <a:rPr lang="en-US" sz="1200" b="0">
+                          <a:solidFill>
+                            <a:srgbClr val="172B4D"/>
+                          </a:solidFill>
+                          <a:latin typeface="Noto Sans CJK SC"/>
+                          <a:ea typeface="Noto Sans CJK SC"/>
+                          <a:cs typeface="Noto Sans CJK SC"/>
+                        </a:rPr>
+                        <a:t>6.96</a:t>
+                      </a:r>
+                      <a:r>
+                        <a:rPr sz="1200" b="0">
+                          <a:solidFill>
+                            <a:srgbClr val="172B4D"/>
+                          </a:solidFill>
+                          <a:latin typeface="Noto Sans CJK SC"/>
+                          <a:ea typeface="Noto Sans CJK SC"/>
+                          <a:cs typeface="Noto Sans CJK SC"/>
+                        </a:rPr>
+                        <a:t>%</a:t>
                       </a:r>
                       <a:endParaRPr sz="1200" b="0">
                         <a:solidFill>
@@ -17147,7 +17345,29 @@
                           <a:ea typeface="Noto Sans CJK SC"/>
                           <a:cs typeface="Noto Sans CJK SC"/>
                         </a:rPr>
-                        <a:t>88.74%</a:t>
+                        <a:t>88.</a:t>
+                      </a:r>
+                      <a:r>
+                        <a:rPr lang="en-US" sz="1200" b="0">
+                          <a:solidFill>
+                            <a:srgbClr val="172B4D"/>
+                          </a:solidFill>
+                          <a:latin typeface="Noto Sans CJK SC"/>
+                          <a:ea typeface="Noto Sans CJK SC"/>
+                          <a:cs typeface="Noto Sans CJK SC"/>
+                        </a:rPr>
+                        <a:t>50</a:t>
+                      </a:r>
+                      <a:r>
+                        <a:rPr sz="1200" b="0">
+                          <a:solidFill>
+                            <a:srgbClr val="172B4D"/>
+                          </a:solidFill>
+                          <a:latin typeface="Noto Sans CJK SC"/>
+                          <a:ea typeface="Noto Sans CJK SC"/>
+                          <a:cs typeface="Noto Sans CJK SC"/>
+                        </a:rPr>
+                        <a:t>%</a:t>
                       </a:r>
                       <a:endParaRPr sz="1200" b="0">
                         <a:solidFill>
@@ -17252,6 +17472,17 @@
                         <a:buNone/>
                       </a:pPr>
                       <a:r>
+                        <a:rPr lang="en-US" sz="1200" b="0">
+                          <a:solidFill>
+                            <a:srgbClr val="172B4D"/>
+                          </a:solidFill>
+                          <a:latin typeface="Noto Sans CJK SC"/>
+                          <a:ea typeface="Noto Sans CJK SC"/>
+                          <a:cs typeface="Noto Sans CJK SC"/>
+                        </a:rPr>
+                        <a:t>55.00</a:t>
+                      </a:r>
+                      <a:r>
                         <a:rPr sz="1200" b="0">
                           <a:solidFill>
                             <a:srgbClr val="172B4D"/>
@@ -17260,7 +17491,7 @@
                           <a:ea typeface="Noto Sans CJK SC"/>
                           <a:cs typeface="Noto Sans CJK SC"/>
                         </a:rPr>
-                        <a:t>65.00%</a:t>
+                        <a:t>%</a:t>
                       </a:r>
                       <a:endParaRPr sz="1200" b="0">
                         <a:solidFill>
@@ -17289,6 +17520,17 @@
                         <a:buNone/>
                       </a:pPr>
                       <a:r>
+                        <a:rPr lang="en-US" sz="1200" b="0">
+                          <a:solidFill>
+                            <a:srgbClr val="172B4D"/>
+                          </a:solidFill>
+                          <a:latin typeface="Noto Sans CJK SC"/>
+                          <a:ea typeface="Noto Sans CJK SC"/>
+                          <a:cs typeface="Noto Sans CJK SC"/>
+                        </a:rPr>
+                        <a:t>60.27</a:t>
+                      </a:r>
+                      <a:r>
                         <a:rPr sz="1200" b="0">
                           <a:solidFill>
                             <a:srgbClr val="172B4D"/>
@@ -17297,7 +17539,7 @@
                           <a:ea typeface="Noto Sans CJK SC"/>
                           <a:cs typeface="Noto Sans CJK SC"/>
                         </a:rPr>
-                        <a:t>70.27%</a:t>
+                        <a:t>%</a:t>
                       </a:r>
                       <a:endParaRPr sz="1200" b="0">
                         <a:solidFill>
@@ -17402,6 +17644,17 @@
                         <a:buNone/>
                       </a:pPr>
                       <a:r>
+                        <a:rPr lang="en-US" sz="1200" b="0">
+                          <a:solidFill>
+                            <a:srgbClr val="172B4D"/>
+                          </a:solidFill>
+                          <a:latin typeface="Noto Sans CJK SC"/>
+                          <a:ea typeface="Noto Sans CJK SC"/>
+                          <a:cs typeface="Noto Sans CJK SC"/>
+                        </a:rPr>
+                        <a:t>85</a:t>
+                      </a:r>
+                      <a:r>
                         <a:rPr sz="1200" b="0">
                           <a:solidFill>
                             <a:srgbClr val="172B4D"/>
@@ -17410,7 +17663,7 @@
                           <a:ea typeface="Noto Sans CJK SC"/>
                           <a:cs typeface="Noto Sans CJK SC"/>
                         </a:rPr>
-                        <a:t>90.00%</a:t>
+                        <a:t>.00%</a:t>
                       </a:r>
                       <a:endParaRPr sz="1200" b="0">
                         <a:solidFill>
@@ -17447,7 +17700,51 @@
                           <a:ea typeface="Noto Sans CJK SC"/>
                           <a:cs typeface="Noto Sans CJK SC"/>
                         </a:rPr>
-                        <a:t>76.60%</a:t>
+                        <a:t>7</a:t>
+                      </a:r>
+                      <a:r>
+                        <a:rPr lang="en-US" sz="1200" b="0">
+                          <a:solidFill>
+                            <a:srgbClr val="172B4D"/>
+                          </a:solidFill>
+                          <a:latin typeface="Noto Sans CJK SC"/>
+                          <a:ea typeface="Noto Sans CJK SC"/>
+                          <a:cs typeface="Noto Sans CJK SC"/>
+                        </a:rPr>
+                        <a:t>1</a:t>
+                      </a:r>
+                      <a:r>
+                        <a:rPr sz="1200" b="0">
+                          <a:solidFill>
+                            <a:srgbClr val="172B4D"/>
+                          </a:solidFill>
+                          <a:latin typeface="Noto Sans CJK SC"/>
+                          <a:ea typeface="Noto Sans CJK SC"/>
+                          <a:cs typeface="Noto Sans CJK SC"/>
+                        </a:rPr>
+                        <a:t>.</a:t>
+                      </a:r>
+                      <a:r>
+                        <a:rPr lang="en-US" sz="1200" b="0">
+                          <a:solidFill>
+                            <a:srgbClr val="172B4D"/>
+                          </a:solidFill>
+                          <a:latin typeface="Noto Sans CJK SC"/>
+                          <a:ea typeface="Noto Sans CJK SC"/>
+                          <a:cs typeface="Noto Sans CJK SC"/>
+                        </a:rPr>
+                        <a:t>58</a:t>
+                      </a:r>
+                      <a:r>
+                        <a:rPr sz="1200" b="0">
+                          <a:solidFill>
+                            <a:srgbClr val="172B4D"/>
+                          </a:solidFill>
+                          <a:latin typeface="Noto Sans CJK SC"/>
+                          <a:ea typeface="Noto Sans CJK SC"/>
+                          <a:cs typeface="Noto Sans CJK SC"/>
+                        </a:rPr>
+                        <a:t>%</a:t>
                       </a:r>
                       <a:endParaRPr sz="1200" b="0">
                         <a:solidFill>
@@ -17552,6 +17849,17 @@
                         <a:buNone/>
                       </a:pPr>
                       <a:r>
+                        <a:rPr lang="en-US" sz="1200" b="0">
+                          <a:solidFill>
+                            <a:srgbClr val="172B4D"/>
+                          </a:solidFill>
+                          <a:latin typeface="Noto Sans CJK SC"/>
+                          <a:ea typeface="Noto Sans CJK SC"/>
+                          <a:cs typeface="Noto Sans CJK SC"/>
+                        </a:rPr>
+                        <a:t>8</a:t>
+                      </a:r>
+                      <a:r>
                         <a:rPr sz="1200" b="0">
                           <a:solidFill>
                             <a:srgbClr val="172B4D"/>
@@ -17560,7 +17868,7 @@
                           <a:ea typeface="Noto Sans CJK SC"/>
                           <a:cs typeface="Noto Sans CJK SC"/>
                         </a:rPr>
-                        <a:t>95.00%</a:t>
+                        <a:t>5.00%</a:t>
                       </a:r>
                       <a:endParaRPr sz="1200" b="0">
                         <a:solidFill>
@@ -17597,7 +17905,29 @@
                           <a:ea typeface="Noto Sans CJK SC"/>
                           <a:cs typeface="Noto Sans CJK SC"/>
                         </a:rPr>
-                        <a:t>88.37%</a:t>
+                        <a:t>8</a:t>
+                      </a:r>
+                      <a:r>
+                        <a:rPr lang="en-US" sz="1200" b="0">
+                          <a:solidFill>
+                            <a:srgbClr val="172B4D"/>
+                          </a:solidFill>
+                          <a:latin typeface="Noto Sans CJK SC"/>
+                          <a:ea typeface="Noto Sans CJK SC"/>
+                          <a:cs typeface="Noto Sans CJK SC"/>
+                        </a:rPr>
+                        <a:t>6.08</a:t>
+                      </a:r>
+                      <a:r>
+                        <a:rPr sz="1200" b="0">
+                          <a:solidFill>
+                            <a:srgbClr val="172B4D"/>
+                          </a:solidFill>
+                          <a:latin typeface="Noto Sans CJK SC"/>
+                          <a:ea typeface="Noto Sans CJK SC"/>
+                          <a:cs typeface="Noto Sans CJK SC"/>
+                        </a:rPr>
+                        <a:t>%</a:t>
                       </a:r>
                       <a:endParaRPr sz="1200" b="0">
                         <a:solidFill>
@@ -17702,6 +18032,17 @@
                         <a:buNone/>
                       </a:pPr>
                       <a:r>
+                        <a:rPr lang="en-US" sz="1200" b="0">
+                          <a:solidFill>
+                            <a:srgbClr val="172B4D"/>
+                          </a:solidFill>
+                          <a:latin typeface="Noto Sans CJK SC"/>
+                          <a:ea typeface="Noto Sans CJK SC"/>
+                          <a:cs typeface="Noto Sans CJK SC"/>
+                        </a:rPr>
+                        <a:t>80</a:t>
+                      </a:r>
+                      <a:r>
                         <a:rPr sz="1200" b="0">
                           <a:solidFill>
                             <a:srgbClr val="172B4D"/>
@@ -17710,7 +18051,7 @@
                           <a:ea typeface="Noto Sans CJK SC"/>
                           <a:cs typeface="Noto Sans CJK SC"/>
                         </a:rPr>
-                        <a:t>75.00%</a:t>
+                        <a:t>.00%</a:t>
                       </a:r>
                       <a:endParaRPr sz="1200" b="0">
                         <a:solidFill>
@@ -17739,6 +18080,17 @@
                         <a:buNone/>
                       </a:pPr>
                       <a:r>
+                        <a:rPr lang="en-US" sz="1200" b="0">
+                          <a:solidFill>
+                            <a:srgbClr val="172B4D"/>
+                          </a:solidFill>
+                          <a:latin typeface="Noto Sans CJK SC"/>
+                          <a:ea typeface="Noto Sans CJK SC"/>
+                          <a:cs typeface="Noto Sans CJK SC"/>
+                        </a:rPr>
+                        <a:t>79.01</a:t>
+                      </a:r>
+                      <a:r>
                         <a:rPr sz="1200" b="0">
                           <a:solidFill>
                             <a:srgbClr val="172B4D"/>
@@ -17747,7 +18099,7 @@
                           <a:ea typeface="Noto Sans CJK SC"/>
                           <a:cs typeface="Noto Sans CJK SC"/>
                         </a:rPr>
-                        <a:t>73.17%</a:t>
+                        <a:t>%</a:t>
                       </a:r>
                       <a:endParaRPr sz="1200" b="0">
                         <a:solidFill>
@@ -17846,7 +18198,29 @@
                 <a:ea typeface="Noto Sans CJK SC"/>
                 <a:cs typeface="Noto Sans CJK SC"/>
               </a:rPr>
-              <a:t>83.85%</a:t>
+              <a:t>8</a:t>
+            </a:r>
+            <a:r>
+              <a:rPr lang="en-US" sz="2550" b="1">
+                <a:solidFill>
+                  <a:srgbClr val="102A43"/>
+                </a:solidFill>
+                <a:latin typeface="Noto Sans CJK SC"/>
+                <a:ea typeface="Noto Sans CJK SC"/>
+                <a:cs typeface="Noto Sans CJK SC"/>
+              </a:rPr>
+              <a:t>2.56</a:t>
+            </a:r>
+            <a:r>
+              <a:rPr sz="2550" b="1">
+                <a:solidFill>
+                  <a:srgbClr val="102A43"/>
+                </a:solidFill>
+                <a:latin typeface="Noto Sans CJK SC"/>
+                <a:ea typeface="Noto Sans CJK SC"/>
+                <a:cs typeface="Noto Sans CJK SC"/>
+              </a:rPr>
+              <a:t>%</a:t>
             </a:r>
             <a:endParaRPr sz="2550" b="1">
               <a:solidFill>
@@ -17991,6 +18365,17 @@
               </a:defRPr>
             </a:pPr>
             <a:r>
+              <a:rPr lang="en-US" sz="2550" b="1">
+                <a:solidFill>
+                  <a:srgbClr val="102A43"/>
+                </a:solidFill>
+                <a:latin typeface="Noto Sans CJK SC"/>
+                <a:ea typeface="Noto Sans CJK SC"/>
+                <a:cs typeface="Noto Sans CJK SC"/>
+              </a:rPr>
+              <a:t>78.39</a:t>
+            </a:r>
+            <a:r>
               <a:rPr sz="2550" b="1">
                 <a:solidFill>
                   <a:srgbClr val="102A43"/>
@@ -17999,7 +18384,7 @@
                 <a:ea typeface="Noto Sans CJK SC"/>
                 <a:cs typeface="Noto Sans CJK SC"/>
               </a:rPr>
-              <a:t>82.13%</a:t>
+              <a:t>%</a:t>
             </a:r>
             <a:endParaRPr sz="2550" b="1">
               <a:solidFill>
@@ -18152,7 +18537,29 @@
                 <a:ea typeface="Noto Sans CJK SC"/>
                 <a:cs typeface="Noto Sans CJK SC"/>
               </a:rPr>
-              <a:t>84.10%</a:t>
+              <a:t>8</a:t>
+            </a:r>
+            <a:r>
+              <a:rPr lang="en-US" sz="2550" b="1">
+                <a:solidFill>
+                  <a:srgbClr val="102A43"/>
+                </a:solidFill>
+                <a:latin typeface="Noto Sans CJK SC"/>
+                <a:ea typeface="Noto Sans CJK SC"/>
+                <a:cs typeface="Noto Sans CJK SC"/>
+              </a:rPr>
+              <a:t>2.56</a:t>
+            </a:r>
+            <a:r>
+              <a:rPr sz="2550" b="1">
+                <a:solidFill>
+                  <a:srgbClr val="102A43"/>
+                </a:solidFill>
+                <a:latin typeface="Noto Sans CJK SC"/>
+                <a:ea typeface="Noto Sans CJK SC"/>
+                <a:cs typeface="Noto Sans CJK SC"/>
+              </a:rPr>
+              <a:t>%</a:t>
             </a:r>
             <a:endParaRPr sz="2550" b="1">
               <a:solidFill>
@@ -18482,7 +18889,7 @@
         </p:nvSpPr>
         <p:spPr>
           <a:xfrm>
-            <a:off x="533400" y="552450"/>
+            <a:off x="533400" y="633095"/>
             <a:ext cx="11125200" cy="514350"/>
           </a:xfrm>
           <a:prstGeom prst="rect">
@@ -18515,7 +18922,7 @@
               </a:defRPr>
             </a:pPr>
             <a:r>
-              <a:rPr sz="2700" b="1">
+              <a:rPr lang="zh-CN" altLang="en-US" sz="2700" b="1">
                 <a:solidFill>
                   <a:srgbClr val="102A43"/>
                 </a:solidFill>
@@ -18523,9 +18930,9 @@
                 <a:ea typeface="Noto Sans CJK SC"/>
                 <a:cs typeface="Noto Sans CJK SC"/>
               </a:rPr>
-              <a:t>强噪声下事件类别容易被判为 background</a:t>
+              <a:t>强噪声下五类事件仍可检出</a:t>
             </a:r>
-            <a:endParaRPr sz="2700" b="1">
+            <a:endParaRPr lang="zh-CN" altLang="en-US" sz="2700" b="1">
               <a:solidFill>
                 <a:srgbClr val="102A43"/>
               </a:solidFill>
@@ -19005,7 +19412,29 @@
                           <a:ea typeface="Noto Sans CJK SC"/>
                           <a:cs typeface="Noto Sans CJK SC"/>
                         </a:rPr>
-                        <a:t>83.85%</a:t>
+                        <a:t>8</a:t>
+                      </a:r>
+                      <a:r>
+                        <a:rPr lang="en-US" sz="975" b="0">
+                          <a:solidFill>
+                            <a:srgbClr val="172B4D"/>
+                          </a:solidFill>
+                          <a:latin typeface="Noto Sans CJK SC"/>
+                          <a:ea typeface="Noto Sans CJK SC"/>
+                          <a:cs typeface="Noto Sans CJK SC"/>
+                        </a:rPr>
+                        <a:t>2.56</a:t>
+                      </a:r>
+                      <a:r>
+                        <a:rPr sz="975" b="0">
+                          <a:solidFill>
+                            <a:srgbClr val="172B4D"/>
+                          </a:solidFill>
+                          <a:latin typeface="Noto Sans CJK SC"/>
+                          <a:ea typeface="Noto Sans CJK SC"/>
+                          <a:cs typeface="Noto Sans CJK SC"/>
+                        </a:rPr>
+                        <a:t>%</a:t>
                       </a:r>
                       <a:endParaRPr sz="975" b="0">
                         <a:solidFill>
@@ -19042,7 +19471,29 @@
                           <a:ea typeface="Noto Sans CJK SC"/>
                           <a:cs typeface="Noto Sans CJK SC"/>
                         </a:rPr>
-                        <a:t>84.10%</a:t>
+                        <a:t>8</a:t>
+                      </a:r>
+                      <a:r>
+                        <a:rPr lang="en-US" sz="975" b="0">
+                          <a:solidFill>
+                            <a:srgbClr val="172B4D"/>
+                          </a:solidFill>
+                          <a:latin typeface="Noto Sans CJK SC"/>
+                          <a:ea typeface="Noto Sans CJK SC"/>
+                          <a:cs typeface="Noto Sans CJK SC"/>
+                        </a:rPr>
+                        <a:t>2.56</a:t>
+                      </a:r>
+                      <a:r>
+                        <a:rPr sz="975" b="0">
+                          <a:solidFill>
+                            <a:srgbClr val="172B4D"/>
+                          </a:solidFill>
+                          <a:latin typeface="Noto Sans CJK SC"/>
+                          <a:ea typeface="Noto Sans CJK SC"/>
+                          <a:cs typeface="Noto Sans CJK SC"/>
+                        </a:rPr>
+                        <a:t>%</a:t>
                       </a:r>
                       <a:endParaRPr sz="975" b="0">
                         <a:solidFill>
@@ -19079,7 +19530,51 @@
                           <a:ea typeface="Noto Sans CJK SC"/>
                           <a:cs typeface="Noto Sans CJK SC"/>
                         </a:rPr>
-                        <a:t>宏召回 82.13% / 82.22%</a:t>
+                        <a:t>宏召回 </a:t>
+                      </a:r>
+                      <a:r>
+                        <a:rPr lang="en-US" sz="975" b="0">
+                          <a:solidFill>
+                            <a:srgbClr val="172B4D"/>
+                          </a:solidFill>
+                          <a:latin typeface="Noto Sans CJK SC"/>
+                          <a:ea typeface="Noto Sans CJK SC"/>
+                          <a:cs typeface="Noto Sans CJK SC"/>
+                        </a:rPr>
+                        <a:t>78.39</a:t>
+                      </a:r>
+                      <a:r>
+                        <a:rPr sz="975" b="0">
+                          <a:solidFill>
+                            <a:srgbClr val="172B4D"/>
+                          </a:solidFill>
+                          <a:latin typeface="Noto Sans CJK SC"/>
+                          <a:ea typeface="Noto Sans CJK SC"/>
+                          <a:cs typeface="Noto Sans CJK SC"/>
+                        </a:rPr>
+                        <a:t>% / </a:t>
+                      </a:r>
+                      <a:r>
+                        <a:rPr lang="en-US" sz="975" b="0">
+                          <a:solidFill>
+                            <a:srgbClr val="172B4D"/>
+                          </a:solidFill>
+                          <a:latin typeface="Noto Sans CJK SC"/>
+                          <a:ea typeface="Noto Sans CJK SC"/>
+                          <a:cs typeface="Noto Sans CJK SC"/>
+                        </a:rPr>
+                        <a:t>78.39</a:t>
+                      </a:r>
+                      <a:r>
+                        <a:rPr sz="975" b="0">
+                          <a:solidFill>
+                            <a:srgbClr val="172B4D"/>
+                          </a:solidFill>
+                          <a:latin typeface="Noto Sans CJK SC"/>
+                          <a:ea typeface="Noto Sans CJK SC"/>
+                          <a:cs typeface="Noto Sans CJK SC"/>
+                        </a:rPr>
+                        <a:t>%</a:t>
                       </a:r>
                       <a:endParaRPr sz="975" b="0">
                         <a:solidFill>
@@ -19155,7 +19650,29 @@
                           <a:ea typeface="Noto Sans CJK SC"/>
                           <a:cs typeface="Noto Sans CJK SC"/>
                         </a:rPr>
-                        <a:t>84.87%</a:t>
+                        <a:t>8</a:t>
+                      </a:r>
+                      <a:r>
+                        <a:rPr lang="en-US" sz="975" b="0">
+                          <a:solidFill>
+                            <a:srgbClr val="172B4D"/>
+                          </a:solidFill>
+                          <a:latin typeface="Noto Sans CJK SC"/>
+                          <a:ea typeface="Noto Sans CJK SC"/>
+                          <a:cs typeface="Noto Sans CJK SC"/>
+                        </a:rPr>
+                        <a:t>0.00</a:t>
+                      </a:r>
+                      <a:r>
+                        <a:rPr sz="975" b="0">
+                          <a:solidFill>
+                            <a:srgbClr val="172B4D"/>
+                          </a:solidFill>
+                          <a:latin typeface="Noto Sans CJK SC"/>
+                          <a:ea typeface="Noto Sans CJK SC"/>
+                          <a:cs typeface="Noto Sans CJK SC"/>
+                        </a:rPr>
+                        <a:t>%</a:t>
                       </a:r>
                       <a:endParaRPr sz="975" b="0">
                         <a:solidFill>
@@ -19192,7 +19709,29 @@
                           <a:ea typeface="Noto Sans CJK SC"/>
                           <a:cs typeface="Noto Sans CJK SC"/>
                         </a:rPr>
-                        <a:t>84.36%</a:t>
+                        <a:t>8</a:t>
+                      </a:r>
+                      <a:r>
+                        <a:rPr lang="en-US" sz="975" b="0">
+                          <a:solidFill>
+                            <a:srgbClr val="172B4D"/>
+                          </a:solidFill>
+                          <a:latin typeface="Noto Sans CJK SC"/>
+                          <a:ea typeface="Noto Sans CJK SC"/>
+                          <a:cs typeface="Noto Sans CJK SC"/>
+                        </a:rPr>
+                        <a:t>0.00</a:t>
+                      </a:r>
+                      <a:r>
+                        <a:rPr sz="975" b="0">
+                          <a:solidFill>
+                            <a:srgbClr val="172B4D"/>
+                          </a:solidFill>
+                          <a:latin typeface="Noto Sans CJK SC"/>
+                          <a:ea typeface="Noto Sans CJK SC"/>
+                          <a:cs typeface="Noto Sans CJK SC"/>
+                        </a:rPr>
+                        <a:t>%</a:t>
                       </a:r>
                       <a:endParaRPr sz="975" b="0">
                         <a:solidFill>
@@ -19229,7 +19768,51 @@
                           <a:ea typeface="Noto Sans CJK SC"/>
                           <a:cs typeface="Noto Sans CJK SC"/>
                         </a:rPr>
-                        <a:t>宏召回 78.76% / 77.76%</a:t>
+                        <a:t>宏召回 78</a:t>
+                      </a:r>
+                      <a:r>
+                        <a:rPr lang="en-US" sz="975" b="0">
+                          <a:solidFill>
+                            <a:srgbClr val="172B4D"/>
+                          </a:solidFill>
+                          <a:latin typeface="Noto Sans CJK SC"/>
+                          <a:ea typeface="Noto Sans CJK SC"/>
+                          <a:cs typeface="Noto Sans CJK SC"/>
+                        </a:rPr>
+                        <a:t>.76</a:t>
+                      </a:r>
+                      <a:r>
+                        <a:rPr sz="975" b="0">
+                          <a:solidFill>
+                            <a:srgbClr val="172B4D"/>
+                          </a:solidFill>
+                          <a:latin typeface="Noto Sans CJK SC"/>
+                          <a:ea typeface="Noto Sans CJK SC"/>
+                          <a:cs typeface="Noto Sans CJK SC"/>
+                        </a:rPr>
+                        <a:t>% / 7</a:t>
+                      </a:r>
+                      <a:r>
+                        <a:rPr lang="en-US" sz="975" b="0">
+                          <a:solidFill>
+                            <a:srgbClr val="172B4D"/>
+                          </a:solidFill>
+                          <a:latin typeface="Noto Sans CJK SC"/>
+                          <a:ea typeface="Noto Sans CJK SC"/>
+                          <a:cs typeface="Noto Sans CJK SC"/>
+                        </a:rPr>
+                        <a:t>9.17</a:t>
+                      </a:r>
+                      <a:r>
+                        <a:rPr sz="975" b="0">
+                          <a:solidFill>
+                            <a:srgbClr val="172B4D"/>
+                          </a:solidFill>
+                          <a:latin typeface="Noto Sans CJK SC"/>
+                          <a:ea typeface="Noto Sans CJK SC"/>
+                          <a:cs typeface="Noto Sans CJK SC"/>
+                        </a:rPr>
+                        <a:t>%</a:t>
                       </a:r>
                       <a:endParaRPr sz="975" b="0">
                         <a:solidFill>
@@ -19305,7 +19888,29 @@
                           <a:ea typeface="Noto Sans CJK SC"/>
                           <a:cs typeface="Noto Sans CJK SC"/>
                         </a:rPr>
-                        <a:t>71.54%</a:t>
+                        <a:t>7</a:t>
+                      </a:r>
+                      <a:r>
+                        <a:rPr lang="en-US" sz="975" b="0">
+                          <a:solidFill>
+                            <a:srgbClr val="172B4D"/>
+                          </a:solidFill>
+                          <a:latin typeface="Noto Sans CJK SC"/>
+                          <a:ea typeface="Noto Sans CJK SC"/>
+                          <a:cs typeface="Noto Sans CJK SC"/>
+                        </a:rPr>
+                        <a:t>9.23</a:t>
+                      </a:r>
+                      <a:r>
+                        <a:rPr sz="975" b="0">
+                          <a:solidFill>
+                            <a:srgbClr val="172B4D"/>
+                          </a:solidFill>
+                          <a:latin typeface="Noto Sans CJK SC"/>
+                          <a:ea typeface="Noto Sans CJK SC"/>
+                          <a:cs typeface="Noto Sans CJK SC"/>
+                        </a:rPr>
+                        <a:t>%</a:t>
                       </a:r>
                       <a:endParaRPr sz="975" b="0">
                         <a:solidFill>
@@ -19342,7 +19947,29 @@
                           <a:ea typeface="Noto Sans CJK SC"/>
                           <a:cs typeface="Noto Sans CJK SC"/>
                         </a:rPr>
-                        <a:t>71.79%</a:t>
+                        <a:t>7</a:t>
+                      </a:r>
+                      <a:r>
+                        <a:rPr lang="en-US" sz="975" b="0">
+                          <a:solidFill>
+                            <a:srgbClr val="172B4D"/>
+                          </a:solidFill>
+                          <a:latin typeface="Noto Sans CJK SC"/>
+                          <a:ea typeface="Noto Sans CJK SC"/>
+                          <a:cs typeface="Noto Sans CJK SC"/>
+                        </a:rPr>
+                        <a:t>9.23</a:t>
+                      </a:r>
+                      <a:r>
+                        <a:rPr sz="975" b="0">
+                          <a:solidFill>
+                            <a:srgbClr val="172B4D"/>
+                          </a:solidFill>
+                          <a:latin typeface="Noto Sans CJK SC"/>
+                          <a:ea typeface="Noto Sans CJK SC"/>
+                          <a:cs typeface="Noto Sans CJK SC"/>
+                        </a:rPr>
+                        <a:t>%</a:t>
                       </a:r>
                       <a:endParaRPr sz="975" b="0">
                         <a:solidFill>
@@ -19379,7 +20006,51 @@
                           <a:ea typeface="Noto Sans CJK SC"/>
                           <a:cs typeface="Noto Sans CJK SC"/>
                         </a:rPr>
-                        <a:t>宏召回 52.35% / 52.85%</a:t>
+                        <a:t>宏召回 </a:t>
+                      </a:r>
+                      <a:r>
+                        <a:rPr lang="en-US" sz="975" b="0">
+                          <a:solidFill>
+                            <a:srgbClr val="172B4D"/>
+                          </a:solidFill>
+                          <a:latin typeface="Noto Sans CJK SC"/>
+                          <a:ea typeface="Noto Sans CJK SC"/>
+                          <a:cs typeface="Noto Sans CJK SC"/>
+                        </a:rPr>
+                        <a:t>80.57</a:t>
+                      </a:r>
+                      <a:r>
+                        <a:rPr sz="975" b="0">
+                          <a:solidFill>
+                            <a:srgbClr val="172B4D"/>
+                          </a:solidFill>
+                          <a:latin typeface="Noto Sans CJK SC"/>
+                          <a:ea typeface="Noto Sans CJK SC"/>
+                          <a:cs typeface="Noto Sans CJK SC"/>
+                        </a:rPr>
+                        <a:t>% / </a:t>
+                      </a:r>
+                      <a:r>
+                        <a:rPr lang="en-US" sz="975" b="0">
+                          <a:solidFill>
+                            <a:srgbClr val="172B4D"/>
+                          </a:solidFill>
+                          <a:latin typeface="Noto Sans CJK SC"/>
+                          <a:ea typeface="Noto Sans CJK SC"/>
+                          <a:cs typeface="Noto Sans CJK SC"/>
+                        </a:rPr>
+                        <a:t>80.15</a:t>
+                      </a:r>
+                      <a:r>
+                        <a:rPr sz="975" b="0">
+                          <a:solidFill>
+                            <a:srgbClr val="172B4D"/>
+                          </a:solidFill>
+                          <a:latin typeface="Noto Sans CJK SC"/>
+                          <a:ea typeface="Noto Sans CJK SC"/>
+                          <a:cs typeface="Noto Sans CJK SC"/>
+                        </a:rPr>
+                        <a:t>%</a:t>
                       </a:r>
                       <a:endParaRPr sz="975" b="0">
                         <a:solidFill>
@@ -19447,6 +20118,17 @@
                         <a:buNone/>
                       </a:pPr>
                       <a:r>
+                        <a:rPr lang="en-US" sz="975" b="0">
+                          <a:solidFill>
+                            <a:srgbClr val="172B4D"/>
+                          </a:solidFill>
+                          <a:latin typeface="Noto Sans CJK SC"/>
+                          <a:ea typeface="Noto Sans CJK SC"/>
+                          <a:cs typeface="Noto Sans CJK SC"/>
+                        </a:rPr>
+                        <a:t>74.36</a:t>
+                      </a:r>
+                      <a:r>
                         <a:rPr sz="975" b="0">
                           <a:solidFill>
                             <a:srgbClr val="172B4D"/>
@@ -19455,7 +20137,55 @@
                           <a:ea typeface="Noto Sans CJK SC"/>
                           <a:cs typeface="Noto Sans CJK SC"/>
                         </a:rPr>
-                        <a:t>62.82%</a:t>
+                        <a:t>%</a:t>
+                      </a:r>
+                      <a:endParaRPr sz="975" b="0">
+                        <a:solidFill>
+                          <a:srgbClr val="172B4D"/>
+                        </a:solidFill>
+                        <a:latin typeface="Noto Sans CJK SC"/>
+                        <a:ea typeface="Noto Sans CJK SC"/>
+                        <a:cs typeface="Noto Sans CJK SC"/>
+                      </a:endParaRPr>
+                    </a:p>
+                  </a:txBody>
+                  <a:tcPr marL="95250" marR="95250" marT="47625" marB="47625" anchor="ctr">
+                    <a:solidFill>
+                      <a:srgbClr val="F4F8FB"/>
+                    </a:solidFill>
+                  </a:tcPr>
+                </a:tc>
+                <a:tc>
+                  <a:txBody>
+                    <a:bodyPr>
+                      <a:spAutoFit/>
+                    </a:bodyPr>
+                    <a:lstStyle/>
+                    <a:p>
+                      <a:pPr algn="ctr">
+                        <a:buNone/>
+                      </a:pPr>
+                      <a:r>
+                        <a:rPr lang="en-US" sz="975" b="0">
+                          <a:solidFill>
+                            <a:srgbClr val="172B4D"/>
+                          </a:solidFill>
+                          <a:latin typeface="Noto Sans CJK SC"/>
+                          <a:ea typeface="Noto Sans CJK SC"/>
+                          <a:cs typeface="Noto Sans CJK SC"/>
+                        </a:rPr>
+                        <a:t>74.87</a:t>
+                      </a:r>
+                      <a:r>
+                        <a:rPr sz="975" b="0">
+                          <a:solidFill>
+                            <a:srgbClr val="172B4D"/>
+                          </a:solidFill>
+                          <a:latin typeface="Noto Sans CJK SC"/>
+                          <a:ea typeface="Noto Sans CJK SC"/>
+                          <a:cs typeface="Noto Sans CJK SC"/>
+                        </a:rPr>
+                        <a:t>%</a:t>
                       </a:r>
                       <a:endParaRPr sz="975" b="0">
                         <a:solidFill>
@@ -19492,34 +20222,19 @@
                           <a:ea typeface="Noto Sans CJK SC"/>
                           <a:cs typeface="Noto Sans CJK SC"/>
                         </a:rPr>
-                        <a:t>63.08%</a:t>
+                        <a:t>宏召回 </a:t>
                       </a:r>
-                      <a:endParaRPr sz="975" b="0">
-                        <a:solidFill>
-                          <a:srgbClr val="172B4D"/>
-                        </a:solidFill>
-                        <a:latin typeface="Noto Sans CJK SC"/>
-                        <a:ea typeface="Noto Sans CJK SC"/>
-                        <a:cs typeface="Noto Sans CJK SC"/>
-                      </a:endParaRPr>
-                    </a:p>
-                  </a:txBody>
-                  <a:tcPr marL="95250" marR="95250" marT="47625" marB="47625" anchor="ctr">
-                    <a:solidFill>
-                      <a:srgbClr val="F4F8FB"/>
-                    </a:solidFill>
-                  </a:tcPr>
-                </a:tc>
-                <a:tc>
-                  <a:txBody>
-                    <a:bodyPr>
-                      <a:spAutoFit/>
-                    </a:bodyPr>
-                    <a:lstStyle/>
-                    <a:p>
-                      <a:pPr algn="ctr">
-                        <a:buNone/>
-                      </a:pPr>
+                      <a:r>
+                        <a:rPr lang="en-US" sz="975" b="0">
+                          <a:solidFill>
+                            <a:srgbClr val="172B4D"/>
+                          </a:solidFill>
+                          <a:latin typeface="Noto Sans CJK SC"/>
+                          <a:ea typeface="Noto Sans CJK SC"/>
+                          <a:cs typeface="Noto Sans CJK SC"/>
+                        </a:rPr>
+                        <a:t>74.37</a:t>
+                      </a:r>
                       <a:r>
                         <a:rPr sz="975" b="0">
                           <a:solidFill>
@@ -19529,7 +20244,29 @@
                           <a:ea typeface="Noto Sans CJK SC"/>
                           <a:cs typeface="Noto Sans CJK SC"/>
                         </a:rPr>
-                        <a:t>宏召回 33.70% / 34.20%</a:t>
+                        <a:t>% / </a:t>
+                      </a:r>
+                      <a:r>
+                        <a:rPr lang="en-US" sz="975" b="0">
+                          <a:solidFill>
+                            <a:srgbClr val="172B4D"/>
+                          </a:solidFill>
+                          <a:latin typeface="Noto Sans CJK SC"/>
+                          <a:ea typeface="Noto Sans CJK SC"/>
+                          <a:cs typeface="Noto Sans CJK SC"/>
+                        </a:rPr>
+                        <a:t>74.54</a:t>
+                      </a:r>
+                      <a:r>
+                        <a:rPr sz="975" b="0">
+                          <a:solidFill>
+                            <a:srgbClr val="172B4D"/>
+                          </a:solidFill>
+                          <a:latin typeface="Noto Sans CJK SC"/>
+                          <a:ea typeface="Noto Sans CJK SC"/>
+                          <a:cs typeface="Noto Sans CJK SC"/>
+                        </a:rPr>
+                        <a:t>%</a:t>
                       </a:r>
                       <a:endParaRPr sz="975" b="0">
                         <a:solidFill>
@@ -19597,6 +20334,17 @@
                         <a:buNone/>
                       </a:pPr>
                       <a:r>
+                        <a:rPr lang="en-US" sz="975" b="0">
+                          <a:solidFill>
+                            <a:srgbClr val="172B4D"/>
+                          </a:solidFill>
+                          <a:latin typeface="Noto Sans CJK SC"/>
+                          <a:ea typeface="Noto Sans CJK SC"/>
+                          <a:cs typeface="Noto Sans CJK SC"/>
+                        </a:rPr>
+                        <a:t>74.35</a:t>
+                      </a:r>
+                      <a:r>
                         <a:rPr sz="975" b="0">
                           <a:solidFill>
                             <a:srgbClr val="172B4D"/>
@@ -19605,7 +20353,7 @@
                           <a:ea typeface="Noto Sans CJK SC"/>
                           <a:cs typeface="Noto Sans CJK SC"/>
                         </a:rPr>
-                        <a:t>93.48%</a:t>
+                        <a:t>%</a:t>
                       </a:r>
                       <a:endParaRPr sz="975" b="0">
                         <a:solidFill>
@@ -19671,7 +20419,7 @@
                         <a:buNone/>
                       </a:pPr>
                       <a:r>
-                        <a:rPr sz="975" b="0">
+                        <a:rPr lang="zh-CN" altLang="en-US" sz="975" b="0">
                           <a:solidFill>
                             <a:srgbClr val="172B4D"/>
                           </a:solidFill>
@@ -19679,9 +20427,42 @@
                           <a:ea typeface="Noto Sans CJK SC"/>
                           <a:cs typeface="Noto Sans CJK SC"/>
                         </a:rPr>
-                        <a:t>大类撑高总体准确率</a:t>
+                        <a:t>可检出</a:t>
                       </a:r>
-                      <a:endParaRPr sz="975" b="0">
+                      <a:r>
+                        <a:rPr lang="en-US" altLang="zh-CN" sz="975" b="0">
+                          <a:solidFill>
+                            <a:srgbClr val="172B4D"/>
+                          </a:solidFill>
+                          <a:latin typeface="Noto Sans CJK SC"/>
+                          <a:ea typeface="Noto Sans CJK SC"/>
+                          <a:cs typeface="Noto Sans CJK SC"/>
+                        </a:rPr>
+                        <a:t>，</a:t>
+                      </a:r>
+                      <a:r>
+                        <a:rPr lang="zh-CN" altLang="en-US" sz="975" b="0">
+                          <a:solidFill>
+                            <a:srgbClr val="172B4D"/>
+                          </a:solidFill>
+                          <a:latin typeface="Noto Sans CJK SC"/>
+                          <a:ea typeface="Noto Sans CJK SC"/>
+                          <a:cs typeface="Noto Sans CJK SC"/>
+                        </a:rPr>
+                        <a:t>但</a:t>
+                      </a:r>
+                      <a:r>
+                        <a:rPr lang="zh-CN" altLang="en-US" sz="975" b="0">
+                          <a:solidFill>
+                            <a:srgbClr val="172B4D"/>
+                          </a:solidFill>
+                          <a:latin typeface="Noto Sans CJK SC"/>
+                          <a:ea typeface="Noto Sans CJK SC"/>
+                          <a:cs typeface="Noto Sans CJK SC"/>
+                        </a:rPr>
+                        <a:t>准确率下降</a:t>
+                      </a:r>
+                      <a:endParaRPr lang="zh-CN" altLang="en-US" sz="975" b="0">
                         <a:solidFill>
                           <a:srgbClr val="172B4D"/>
                         </a:solidFill>
@@ -19746,6 +20527,17 @@
                       <a:pPr algn="ctr">
                         <a:buNone/>
                       </a:pPr>
+                      <a:r>
+                        <a:rPr lang="en-US" sz="975" b="0">
+                          <a:solidFill>
+                            <a:srgbClr val="172B4D"/>
+                          </a:solidFill>
+                          <a:latin typeface="Noto Sans CJK SC"/>
+                          <a:ea typeface="Noto Sans CJK SC"/>
+                          <a:cs typeface="Noto Sans CJK SC"/>
+                        </a:rPr>
+                        <a:t>4</a:t>
+                      </a:r>
                       <a:r>
                         <a:rPr sz="975" b="0">
                           <a:solidFill>
@@ -19897,6 +20689,17 @@
                         <a:buNone/>
                       </a:pPr>
                       <a:r>
+                        <a:rPr lang="en-US" sz="975" b="0">
+                          <a:solidFill>
+                            <a:srgbClr val="172B4D"/>
+                          </a:solidFill>
+                          <a:latin typeface="Noto Sans CJK SC"/>
+                          <a:ea typeface="Noto Sans CJK SC"/>
+                          <a:cs typeface="Noto Sans CJK SC"/>
+                        </a:rPr>
+                        <a:t>82</a:t>
+                      </a:r>
+                      <a:r>
                         <a:rPr sz="975" b="0">
                           <a:solidFill>
                             <a:srgbClr val="172B4D"/>
@@ -19905,7 +20708,29 @@
                           <a:ea typeface="Noto Sans CJK SC"/>
                           <a:cs typeface="Noto Sans CJK SC"/>
                         </a:rPr>
-                        <a:t>45.00%</a:t>
+                        <a:t>.</a:t>
+                      </a:r>
+                      <a:r>
+                        <a:rPr lang="en-US" sz="975" b="0">
+                          <a:solidFill>
+                            <a:srgbClr val="172B4D"/>
+                          </a:solidFill>
+                          <a:latin typeface="Noto Sans CJK SC"/>
+                          <a:ea typeface="Noto Sans CJK SC"/>
+                          <a:cs typeface="Noto Sans CJK SC"/>
+                        </a:rPr>
+                        <a:t>5</a:t>
+                      </a:r>
+                      <a:r>
+                        <a:rPr sz="975" b="0">
+                          <a:solidFill>
+                            <a:srgbClr val="172B4D"/>
+                          </a:solidFill>
+                          <a:latin typeface="Noto Sans CJK SC"/>
+                          <a:ea typeface="Noto Sans CJK SC"/>
+                          <a:cs typeface="Noto Sans CJK SC"/>
+                        </a:rPr>
+                        <a:t>0%</a:t>
                       </a:r>
                       <a:endParaRPr sz="975" b="0">
                         <a:solidFill>
@@ -19971,7 +20796,7 @@
                         <a:buNone/>
                       </a:pPr>
                       <a:r>
-                        <a:rPr sz="975" b="0">
+                        <a:rPr lang="zh-CN" sz="975" b="0">
                           <a:solidFill>
                             <a:srgbClr val="172B4D"/>
                           </a:solidFill>
@@ -19979,9 +20804,42 @@
                           <a:ea typeface="Noto Sans CJK SC"/>
                           <a:cs typeface="Noto Sans CJK SC"/>
                         </a:rPr>
-                        <a:t>事件类性能下降</a:t>
+                        <a:t>可检出</a:t>
                       </a:r>
-                      <a:endParaRPr sz="975" b="0">
+                      <a:r>
+                        <a:rPr lang="en-US" altLang="zh-CN" sz="975" b="0">
+                          <a:solidFill>
+                            <a:srgbClr val="172B4D"/>
+                          </a:solidFill>
+                          <a:latin typeface="Noto Sans CJK SC"/>
+                          <a:ea typeface="Noto Sans CJK SC"/>
+                          <a:cs typeface="Noto Sans CJK SC"/>
+                        </a:rPr>
+                        <a:t>，</a:t>
+                      </a:r>
+                      <a:r>
+                        <a:rPr lang="zh-CN" altLang="en-US" sz="975" b="0">
+                          <a:solidFill>
+                            <a:srgbClr val="172B4D"/>
+                          </a:solidFill>
+                          <a:latin typeface="Noto Sans CJK SC"/>
+                          <a:ea typeface="Noto Sans CJK SC"/>
+                          <a:cs typeface="Noto Sans CJK SC"/>
+                        </a:rPr>
+                        <a:t>但</a:t>
+                      </a:r>
+                      <a:r>
+                        <a:rPr lang="zh-CN" altLang="en-US" sz="975" b="0">
+                          <a:solidFill>
+                            <a:srgbClr val="172B4D"/>
+                          </a:solidFill>
+                          <a:latin typeface="Noto Sans CJK SC"/>
+                          <a:ea typeface="Noto Sans CJK SC"/>
+                          <a:cs typeface="Noto Sans CJK SC"/>
+                        </a:rPr>
+                        <a:t>准确率下降</a:t>
+                      </a:r>
+                      <a:endParaRPr lang="zh-CN" altLang="en-US" sz="975" b="0">
                         <a:solidFill>
                           <a:srgbClr val="172B4D"/>
                         </a:solidFill>
@@ -20047,6 +20905,17 @@
                         <a:buNone/>
                       </a:pPr>
                       <a:r>
+                        <a:rPr lang="en-US" sz="975" b="0">
+                          <a:solidFill>
+                            <a:srgbClr val="172B4D"/>
+                          </a:solidFill>
+                          <a:latin typeface="Noto Sans CJK SC"/>
+                          <a:ea typeface="Noto Sans CJK SC"/>
+                          <a:cs typeface="Noto Sans CJK SC"/>
+                        </a:rPr>
+                        <a:t>9</a:t>
+                      </a:r>
+                      <a:r>
                         <a:rPr sz="975" b="0">
                           <a:solidFill>
                             <a:srgbClr val="172B4D"/>
@@ -20055,7 +20924,7 @@
                           <a:ea typeface="Noto Sans CJK SC"/>
                           <a:cs typeface="Noto Sans CJK SC"/>
                         </a:rPr>
-                        <a:t>10.00%</a:t>
+                        <a:t>0.00%</a:t>
                       </a:r>
                       <a:endParaRPr sz="975" b="0">
                         <a:solidFill>
@@ -20121,7 +20990,7 @@
                         <a:buNone/>
                       </a:pPr>
                       <a:r>
-                        <a:rPr sz="975" b="0">
+                        <a:rPr lang="zh-CN" sz="975" b="0">
                           <a:solidFill>
                             <a:srgbClr val="172B4D"/>
                           </a:solidFill>
@@ -20129,9 +20998,42 @@
                           <a:ea typeface="Noto Sans CJK SC"/>
                           <a:cs typeface="Noto Sans CJK SC"/>
                         </a:rPr>
-                        <a:t>事件类性能下降</a:t>
+                        <a:t>可检出</a:t>
                       </a:r>
-                      <a:endParaRPr sz="975" b="0">
+                      <a:r>
+                        <a:rPr lang="en-US" altLang="zh-CN" sz="975" b="0">
+                          <a:solidFill>
+                            <a:srgbClr val="172B4D"/>
+                          </a:solidFill>
+                          <a:latin typeface="Noto Sans CJK SC"/>
+                          <a:ea typeface="Noto Sans CJK SC"/>
+                          <a:cs typeface="Noto Sans CJK SC"/>
+                        </a:rPr>
+                        <a:t>，</a:t>
+                      </a:r>
+                      <a:r>
+                        <a:rPr lang="zh-CN" altLang="en-US" sz="975" b="0">
+                          <a:solidFill>
+                            <a:srgbClr val="172B4D"/>
+                          </a:solidFill>
+                          <a:latin typeface="Noto Sans CJK SC"/>
+                          <a:ea typeface="Noto Sans CJK SC"/>
+                          <a:cs typeface="Noto Sans CJK SC"/>
+                        </a:rPr>
+                        <a:t>但准确率</a:t>
+                      </a:r>
+                      <a:r>
+                        <a:rPr lang="zh-CN" altLang="en-US" sz="975" b="0">
+                          <a:solidFill>
+                            <a:srgbClr val="172B4D"/>
+                          </a:solidFill>
+                          <a:latin typeface="Noto Sans CJK SC"/>
+                          <a:ea typeface="Noto Sans CJK SC"/>
+                          <a:cs typeface="Noto Sans CJK SC"/>
+                        </a:rPr>
+                        <a:t>下降</a:t>
+                      </a:r>
+                      <a:endParaRPr lang="zh-CN" altLang="en-US" sz="975" b="0">
                         <a:solidFill>
                           <a:srgbClr val="172B4D"/>
                         </a:solidFill>
@@ -20197,6 +21099,17 @@
                         <a:buNone/>
                       </a:pPr>
                       <a:r>
+                        <a:rPr lang="en-US" sz="975" b="0">
+                          <a:solidFill>
+                            <a:srgbClr val="172B4D"/>
+                          </a:solidFill>
+                          <a:latin typeface="Noto Sans CJK SC"/>
+                          <a:ea typeface="Noto Sans CJK SC"/>
+                          <a:cs typeface="Noto Sans CJK SC"/>
+                        </a:rPr>
+                        <a:t>77</a:t>
+                      </a:r>
+                      <a:r>
                         <a:rPr sz="975" b="0">
                           <a:solidFill>
                             <a:srgbClr val="172B4D"/>
@@ -20205,7 +21118,7 @@
                           <a:ea typeface="Noto Sans CJK SC"/>
                           <a:cs typeface="Noto Sans CJK SC"/>
                         </a:rPr>
-                        <a:t>12.50%</a:t>
+                        <a:t>.50%</a:t>
                       </a:r>
                       <a:endParaRPr sz="975" b="0">
                         <a:solidFill>
@@ -20271,7 +21184,7 @@
                         <a:buNone/>
                       </a:pPr>
                       <a:r>
-                        <a:rPr sz="975" b="0">
+                        <a:rPr lang="zh-CN" sz="975" b="0">
                           <a:solidFill>
                             <a:srgbClr val="172B4D"/>
                           </a:solidFill>
@@ -20279,9 +21192,42 @@
                           <a:ea typeface="Noto Sans CJK SC"/>
                           <a:cs typeface="Noto Sans CJK SC"/>
                         </a:rPr>
-                        <a:t>事件类性能下降</a:t>
+                        <a:t>可检出</a:t>
                       </a:r>
-                      <a:endParaRPr sz="975" b="0">
+                      <a:r>
+                        <a:rPr lang="en-US" altLang="zh-CN" sz="975" b="0">
+                          <a:solidFill>
+                            <a:srgbClr val="172B4D"/>
+                          </a:solidFill>
+                          <a:latin typeface="Noto Sans CJK SC"/>
+                          <a:ea typeface="Noto Sans CJK SC"/>
+                          <a:cs typeface="Noto Sans CJK SC"/>
+                        </a:rPr>
+                        <a:t>，</a:t>
+                      </a:r>
+                      <a:r>
+                        <a:rPr lang="zh-CN" altLang="en-US" sz="975" b="0">
+                          <a:solidFill>
+                            <a:srgbClr val="172B4D"/>
+                          </a:solidFill>
+                          <a:latin typeface="Noto Sans CJK SC"/>
+                          <a:ea typeface="Noto Sans CJK SC"/>
+                          <a:cs typeface="Noto Sans CJK SC"/>
+                        </a:rPr>
+                        <a:t>但准确率</a:t>
+                      </a:r>
+                      <a:r>
+                        <a:rPr lang="zh-CN" altLang="en-US" sz="975" b="0">
+                          <a:solidFill>
+                            <a:srgbClr val="172B4D"/>
+                          </a:solidFill>
+                          <a:latin typeface="Noto Sans CJK SC"/>
+                          <a:ea typeface="Noto Sans CJK SC"/>
+                          <a:cs typeface="Noto Sans CJK SC"/>
+                        </a:rPr>
+                        <a:t>下降</a:t>
+                      </a:r>
+                      <a:endParaRPr lang="zh-CN" altLang="en-US" sz="975" b="0">
                         <a:solidFill>
                           <a:srgbClr val="172B4D"/>
                         </a:solidFill>
@@ -20378,7 +21324,51 @@
                 <a:ea typeface="Noto Sans CJK SC"/>
                 <a:cs typeface="Noto Sans CJK SC"/>
               </a:rPr>
-              <a:t>84.10%</a:t>
+              <a:t>8</a:t>
+            </a:r>
+            <a:r>
+              <a:rPr lang="en-US" sz="2550" b="1">
+                <a:solidFill>
+                  <a:srgbClr val="102A43"/>
+                </a:solidFill>
+                <a:latin typeface="Noto Sans CJK SC"/>
+                <a:ea typeface="Noto Sans CJK SC"/>
+                <a:cs typeface="Noto Sans CJK SC"/>
+              </a:rPr>
+              <a:t>2</a:t>
+            </a:r>
+            <a:r>
+              <a:rPr sz="2550" b="1">
+                <a:solidFill>
+                  <a:srgbClr val="102A43"/>
+                </a:solidFill>
+                <a:latin typeface="Noto Sans CJK SC"/>
+                <a:ea typeface="Noto Sans CJK SC"/>
+                <a:cs typeface="Noto Sans CJK SC"/>
+              </a:rPr>
+              <a:t>.</a:t>
+            </a:r>
+            <a:r>
+              <a:rPr lang="en-US" sz="2550" b="1">
+                <a:solidFill>
+                  <a:srgbClr val="102A43"/>
+                </a:solidFill>
+                <a:latin typeface="Noto Sans CJK SC"/>
+                <a:ea typeface="Noto Sans CJK SC"/>
+                <a:cs typeface="Noto Sans CJK SC"/>
+              </a:rPr>
+              <a:t>56</a:t>
+            </a:r>
+            <a:r>
+              <a:rPr sz="2550" b="1">
+                <a:solidFill>
+                  <a:srgbClr val="102A43"/>
+                </a:solidFill>
+                <a:latin typeface="Noto Sans CJK SC"/>
+                <a:ea typeface="Noto Sans CJK SC"/>
+                <a:cs typeface="Noto Sans CJK SC"/>
+              </a:rPr>
+              <a:t>%</a:t>
             </a:r>
             <a:endParaRPr sz="2550" b="1">
               <a:solidFill>
@@ -20531,7 +21521,51 @@
                 <a:ea typeface="Noto Sans CJK SC"/>
                 <a:cs typeface="Noto Sans CJK SC"/>
               </a:rPr>
-              <a:t>71.79%</a:t>
+              <a:t>7</a:t>
+            </a:r>
+            <a:r>
+              <a:rPr lang="en-US" sz="2550" b="1">
+                <a:solidFill>
+                  <a:srgbClr val="102A43"/>
+                </a:solidFill>
+                <a:latin typeface="Noto Sans CJK SC"/>
+                <a:ea typeface="Noto Sans CJK SC"/>
+                <a:cs typeface="Noto Sans CJK SC"/>
+              </a:rPr>
+              <a:t>9</a:t>
+            </a:r>
+            <a:r>
+              <a:rPr sz="2550" b="1">
+                <a:solidFill>
+                  <a:srgbClr val="102A43"/>
+                </a:solidFill>
+                <a:latin typeface="Noto Sans CJK SC"/>
+                <a:ea typeface="Noto Sans CJK SC"/>
+                <a:cs typeface="Noto Sans CJK SC"/>
+              </a:rPr>
+              <a:t>.</a:t>
+            </a:r>
+            <a:r>
+              <a:rPr lang="en-US" sz="2550" b="1">
+                <a:solidFill>
+                  <a:srgbClr val="102A43"/>
+                </a:solidFill>
+                <a:latin typeface="Noto Sans CJK SC"/>
+                <a:ea typeface="Noto Sans CJK SC"/>
+                <a:cs typeface="Noto Sans CJK SC"/>
+              </a:rPr>
+              <a:t>23</a:t>
+            </a:r>
+            <a:r>
+              <a:rPr sz="2550" b="1">
+                <a:solidFill>
+                  <a:srgbClr val="102A43"/>
+                </a:solidFill>
+                <a:latin typeface="Noto Sans CJK SC"/>
+                <a:ea typeface="Noto Sans CJK SC"/>
+                <a:cs typeface="Noto Sans CJK SC"/>
+              </a:rPr>
+              <a:t>%</a:t>
             </a:r>
             <a:endParaRPr sz="2550" b="1">
               <a:solidFill>
@@ -20676,6 +21710,17 @@
               </a:defRPr>
             </a:pPr>
             <a:r>
+              <a:rPr lang="en-US" sz="2550" b="1">
+                <a:solidFill>
+                  <a:srgbClr val="102A43"/>
+                </a:solidFill>
+                <a:latin typeface="Noto Sans CJK SC"/>
+                <a:ea typeface="Noto Sans CJK SC"/>
+                <a:cs typeface="Noto Sans CJK SC"/>
+              </a:rPr>
+              <a:t>74.87</a:t>
+            </a:r>
+            <a:r>
               <a:rPr sz="2550" b="1">
                 <a:solidFill>
                   <a:srgbClr val="102A43"/>
@@ -20684,7 +21729,7 @@
                 <a:ea typeface="Noto Sans CJK SC"/>
                 <a:cs typeface="Noto Sans CJK SC"/>
               </a:rPr>
-              <a:t>63.08%</a:t>
+              <a:t>%</a:t>
             </a:r>
             <a:endParaRPr sz="2550" b="1">
               <a:solidFill>
@@ -21749,7 +22794,29 @@
                           <a:ea typeface="Noto Sans CJK SC"/>
                           <a:cs typeface="Noto Sans CJK SC"/>
                         </a:rPr>
-                        <a:t>83.85%</a:t>
+                        <a:t>8</a:t>
+                      </a:r>
+                      <a:r>
+                        <a:rPr lang="en-US" sz="1125" b="0">
+                          <a:solidFill>
+                            <a:srgbClr val="172B4D"/>
+                          </a:solidFill>
+                          <a:latin typeface="Noto Sans CJK SC"/>
+                          <a:ea typeface="Noto Sans CJK SC"/>
+                          <a:cs typeface="Noto Sans CJK SC"/>
+                        </a:rPr>
+                        <a:t>2.56</a:t>
+                      </a:r>
+                      <a:r>
+                        <a:rPr sz="1125" b="0">
+                          <a:solidFill>
+                            <a:srgbClr val="172B4D"/>
+                          </a:solidFill>
+                          <a:latin typeface="Noto Sans CJK SC"/>
+                          <a:ea typeface="Noto Sans CJK SC"/>
+                          <a:cs typeface="Noto Sans CJK SC"/>
+                        </a:rPr>
+                        <a:t>%</a:t>
                       </a:r>
                       <a:endParaRPr sz="1125" b="0">
                         <a:solidFill>
@@ -21786,7 +22853,29 @@
                           <a:ea typeface="Noto Sans CJK SC"/>
                           <a:cs typeface="Noto Sans CJK SC"/>
                         </a:rPr>
-                        <a:t>84.10%</a:t>
+                        <a:t>8</a:t>
+                      </a:r>
+                      <a:r>
+                        <a:rPr lang="en-US" sz="1125" b="0">
+                          <a:solidFill>
+                            <a:srgbClr val="172B4D"/>
+                          </a:solidFill>
+                          <a:latin typeface="Noto Sans CJK SC"/>
+                          <a:ea typeface="Noto Sans CJK SC"/>
+                          <a:cs typeface="Noto Sans CJK SC"/>
+                        </a:rPr>
+                        <a:t>2.56</a:t>
+                      </a:r>
+                      <a:r>
+                        <a:rPr sz="1125" b="0">
+                          <a:solidFill>
+                            <a:srgbClr val="172B4D"/>
+                          </a:solidFill>
+                          <a:latin typeface="Noto Sans CJK SC"/>
+                          <a:ea typeface="Noto Sans CJK SC"/>
+                          <a:cs typeface="Noto Sans CJK SC"/>
+                        </a:rPr>
+                        <a:t>%</a:t>
                       </a:r>
                       <a:endParaRPr sz="1125" b="0">
                         <a:solidFill>
@@ -21819,7 +22908,7 @@
         </p:nvSpPr>
         <p:spPr>
           <a:xfrm>
-            <a:off x="6191250" y="4362450"/>
+            <a:off x="6168390" y="4437380"/>
             <a:ext cx="5467350" cy="1028700"/>
           </a:xfrm>
           <a:prstGeom prst="roundRect">
@@ -21846,7 +22935,7 @@
         </p:nvSpPr>
         <p:spPr>
           <a:xfrm>
-            <a:off x="6457950" y="4572000"/>
+            <a:off x="6456045" y="4509135"/>
             <a:ext cx="4762500" cy="323850"/>
           </a:xfrm>
           <a:prstGeom prst="rect">
@@ -21910,7 +22999,7 @@
         </p:nvSpPr>
         <p:spPr>
           <a:xfrm>
-            <a:off x="6457950" y="5000625"/>
+            <a:off x="6457950" y="5085080"/>
             <a:ext cx="4762500" cy="228600"/>
           </a:xfrm>
           <a:prstGeom prst="rect">
@@ -21951,7 +23040,7 @@
                 <a:ea typeface="Noto Sans CJK SC"/>
                 <a:cs typeface="Noto Sans CJK SC"/>
               </a:rPr>
-              <a:t>当前仍使用 float32 激活和运算，本项目不声明纯整数 MAC 加速。</a:t>
+              <a:t>当前仍使用 float32 激活和运算</a:t>
             </a:r>
             <a:endParaRPr sz="1125" b="0">
               <a:solidFill>

</xml_diff>